<commit_message>
modified section logo in the header
</commit_message>
<xml_diff>
--- a/Part 1-Introduction/1_Introduction to Data Mining.pptx
+++ b/Part 1-Introduction/1_Introduction to Data Mining.pptx
@@ -139,6 +139,14 @@
     </p:ext>
   </p:extLst>
 </p:presentation>
+</file>
+
+<file path=ppt/revisionInfo.xml><?xml version="1.0" encoding="utf-8"?>
+<p1510:revInfo xmlns:a="http://schemas.openxmlformats.org/drawingml/2006/main" xmlns:r="http://schemas.openxmlformats.org/officeDocument/2006/relationships" xmlns:p1510="http://schemas.microsoft.com/office/powerpoint/2015/10/main">
+  <p1510:revLst>
+    <p1510:client id="{D1859E10-E91F-4CD4-B9AD-657F2116AC8C}" v="1" dt="2024-11-09T05:23:04.312"/>
+  </p1510:revLst>
+</p1510:revInfo>
 </file>
 
 <file path=ppt/changesInfos/changesInfo1.xml><?xml version="1.0" encoding="utf-8"?>
@@ -842,6 +850,38 @@
           </ac:spMkLst>
         </pc:spChg>
       </pc:sldChg>
+    </pc:docChg>
+  </pc:docChgLst>
+  <pc:docChgLst>
+    <pc:chgData name="Mohammed Fasha" userId="cc64f42d-a1a6-4f08-b97b-0c37f877119f" providerId="ADAL" clId="{D1859E10-E91F-4CD4-B9AD-657F2116AC8C}"/>
+    <pc:docChg chg="custSel modMainMaster">
+      <pc:chgData name="Mohammed Fasha" userId="cc64f42d-a1a6-4f08-b97b-0c37f877119f" providerId="ADAL" clId="{D1859E10-E91F-4CD4-B9AD-657F2116AC8C}" dt="2024-11-09T05:23:14.444" v="3" actId="1076"/>
+      <pc:docMkLst>
+        <pc:docMk/>
+      </pc:docMkLst>
+      <pc:sldMasterChg chg="addSp delSp modSp mod">
+        <pc:chgData name="Mohammed Fasha" userId="cc64f42d-a1a6-4f08-b97b-0c37f877119f" providerId="ADAL" clId="{D1859E10-E91F-4CD4-B9AD-657F2116AC8C}" dt="2024-11-09T05:23:14.444" v="3" actId="1076"/>
+        <pc:sldMasterMkLst>
+          <pc:docMk/>
+          <pc:sldMasterMk cId="2573801746" sldId="2147483648"/>
+        </pc:sldMasterMkLst>
+        <pc:picChg chg="del">
+          <ac:chgData name="Mohammed Fasha" userId="cc64f42d-a1a6-4f08-b97b-0c37f877119f" providerId="ADAL" clId="{D1859E10-E91F-4CD4-B9AD-657F2116AC8C}" dt="2024-11-09T05:23:03.092" v="0" actId="478"/>
+          <ac:picMkLst>
+            <pc:docMk/>
+            <pc:sldMasterMk cId="2573801746" sldId="2147483648"/>
+            <ac:picMk id="8" creationId="{209681C8-34CA-ECC5-8356-8F92339C24DA}"/>
+          </ac:picMkLst>
+        </pc:picChg>
+        <pc:picChg chg="add mod">
+          <ac:chgData name="Mohammed Fasha" userId="cc64f42d-a1a6-4f08-b97b-0c37f877119f" providerId="ADAL" clId="{D1859E10-E91F-4CD4-B9AD-657F2116AC8C}" dt="2024-11-09T05:23:14.444" v="3" actId="1076"/>
+          <ac:picMkLst>
+            <pc:docMk/>
+            <pc:sldMasterMk cId="2573801746" sldId="2147483648"/>
+            <ac:picMk id="10" creationId="{60C727CE-6255-82CB-CFCB-7738B389789F}"/>
+          </ac:picMkLst>
+        </pc:picChg>
+      </pc:sldMasterChg>
     </pc:docChg>
   </pc:docChgLst>
   <pc:docChgLst>
@@ -2048,7 +2088,7 @@
           <a:p>
             <a:fld id="{D83FB9BE-DA6C-46CF-8E77-0CE63E601AD4}" type="datetimeFigureOut">
               <a:rPr lang="en-US" smtClean="0"/>
-              <a:t>10/21/2024</a:t>
+              <a:t>11/9/2024</a:t>
             </a:fld>
             <a:endParaRPr lang="en-US"/>
           </a:p>
@@ -2246,7 +2286,7 @@
           <a:p>
             <a:fld id="{D83FB9BE-DA6C-46CF-8E77-0CE63E601AD4}" type="datetimeFigureOut">
               <a:rPr lang="en-US" smtClean="0"/>
-              <a:t>10/21/2024</a:t>
+              <a:t>11/9/2024</a:t>
             </a:fld>
             <a:endParaRPr lang="en-US"/>
           </a:p>
@@ -2454,7 +2494,7 @@
           <a:p>
             <a:fld id="{D83FB9BE-DA6C-46CF-8E77-0CE63E601AD4}" type="datetimeFigureOut">
               <a:rPr lang="en-US" smtClean="0"/>
-              <a:t>10/21/2024</a:t>
+              <a:t>11/9/2024</a:t>
             </a:fld>
             <a:endParaRPr lang="en-US"/>
           </a:p>
@@ -2657,7 +2697,7 @@
           <a:p>
             <a:fld id="{D83FB9BE-DA6C-46CF-8E77-0CE63E601AD4}" type="datetimeFigureOut">
               <a:rPr lang="en-US" smtClean="0"/>
-              <a:t>10/21/2024</a:t>
+              <a:t>11/9/2024</a:t>
             </a:fld>
             <a:endParaRPr lang="en-US"/>
           </a:p>
@@ -2932,7 +2972,7 @@
           <a:p>
             <a:fld id="{D83FB9BE-DA6C-46CF-8E77-0CE63E601AD4}" type="datetimeFigureOut">
               <a:rPr lang="en-US" smtClean="0"/>
-              <a:t>10/21/2024</a:t>
+              <a:t>11/9/2024</a:t>
             </a:fld>
             <a:endParaRPr lang="en-US"/>
           </a:p>
@@ -3197,7 +3237,7 @@
           <a:p>
             <a:fld id="{D83FB9BE-DA6C-46CF-8E77-0CE63E601AD4}" type="datetimeFigureOut">
               <a:rPr lang="en-US" smtClean="0"/>
-              <a:t>10/21/2024</a:t>
+              <a:t>11/9/2024</a:t>
             </a:fld>
             <a:endParaRPr lang="en-US"/>
           </a:p>
@@ -3609,7 +3649,7 @@
           <a:p>
             <a:fld id="{D83FB9BE-DA6C-46CF-8E77-0CE63E601AD4}" type="datetimeFigureOut">
               <a:rPr lang="en-US" smtClean="0"/>
-              <a:t>10/21/2024</a:t>
+              <a:t>11/9/2024</a:t>
             </a:fld>
             <a:endParaRPr lang="en-US"/>
           </a:p>
@@ -3750,7 +3790,7 @@
           <a:p>
             <a:fld id="{D83FB9BE-DA6C-46CF-8E77-0CE63E601AD4}" type="datetimeFigureOut">
               <a:rPr lang="en-US" smtClean="0"/>
-              <a:t>10/21/2024</a:t>
+              <a:t>11/9/2024</a:t>
             </a:fld>
             <a:endParaRPr lang="en-US"/>
           </a:p>
@@ -3863,7 +3903,7 @@
           <a:p>
             <a:fld id="{D83FB9BE-DA6C-46CF-8E77-0CE63E601AD4}" type="datetimeFigureOut">
               <a:rPr lang="en-US" smtClean="0"/>
-              <a:t>10/21/2024</a:t>
+              <a:t>11/9/2024</a:t>
             </a:fld>
             <a:endParaRPr lang="en-US"/>
           </a:p>
@@ -4174,7 +4214,7 @@
           <a:p>
             <a:fld id="{D83FB9BE-DA6C-46CF-8E77-0CE63E601AD4}" type="datetimeFigureOut">
               <a:rPr lang="en-US" smtClean="0"/>
-              <a:t>10/21/2024</a:t>
+              <a:t>11/9/2024</a:t>
             </a:fld>
             <a:endParaRPr lang="en-US"/>
           </a:p>
@@ -4462,7 +4502,7 @@
           <a:p>
             <a:fld id="{D83FB9BE-DA6C-46CF-8E77-0CE63E601AD4}" type="datetimeFigureOut">
               <a:rPr lang="en-US" smtClean="0"/>
-              <a:t>10/21/2024</a:t>
+              <a:t>11/9/2024</a:t>
             </a:fld>
             <a:endParaRPr lang="en-US"/>
           </a:p>
@@ -4703,7 +4743,7 @@
           <a:p>
             <a:fld id="{D83FB9BE-DA6C-46CF-8E77-0CE63E601AD4}" type="datetimeFigureOut">
               <a:rPr lang="en-US" smtClean="0"/>
-              <a:t>10/21/2024</a:t>
+              <a:t>11/9/2024</a:t>
             </a:fld>
             <a:endParaRPr lang="en-US"/>
           </a:p>
@@ -4837,42 +4877,6 @@
       </p:pic>
       <p:pic>
         <p:nvPicPr>
-          <p:cNvPr id="8" name="Picture 7">
-            <a:extLst>
-              <a:ext uri="{FF2B5EF4-FFF2-40B4-BE49-F238E27FC236}">
-                <a16:creationId xmlns:a16="http://schemas.microsoft.com/office/drawing/2014/main" id="{209681C8-34CA-ECC5-8356-8F92339C24DA}"/>
-              </a:ext>
-            </a:extLst>
-          </p:cNvPr>
-          <p:cNvPicPr>
-            <a:picLocks noChangeAspect="1"/>
-          </p:cNvPicPr>
-          <p:nvPr userDrawn="1"/>
-        </p:nvPicPr>
-        <p:blipFill>
-          <a:blip r:embed="rId14">
-            <a:extLst>
-              <a:ext uri="{28A0092B-C50C-407E-A947-70E740481C1C}">
-                <a14:useLocalDpi xmlns:a14="http://schemas.microsoft.com/office/drawing/2010/main" val="0"/>
-              </a:ext>
-            </a:extLst>
-          </a:blip>
-          <a:stretch>
-            <a:fillRect/>
-          </a:stretch>
-        </p:blipFill>
-        <p:spPr>
-          <a:xfrm>
-            <a:off x="88965" y="160954"/>
-            <a:ext cx="2120835" cy="636570"/>
-          </a:xfrm>
-          <a:prstGeom prst="rect">
-            <a:avLst/>
-          </a:prstGeom>
-        </p:spPr>
-      </p:pic>
-      <p:pic>
-        <p:nvPicPr>
           <p:cNvPr id="9" name="Picture 8">
             <a:extLst>
               <a:ext uri="{FF2B5EF4-FFF2-40B4-BE49-F238E27FC236}">
@@ -4886,7 +4890,7 @@
           <p:nvPr userDrawn="1"/>
         </p:nvPicPr>
         <p:blipFill>
-          <a:blip r:embed="rId15">
+          <a:blip r:embed="rId14">
             <a:extLst>
               <a:ext uri="{28A0092B-C50C-407E-A947-70E740481C1C}">
                 <a14:useLocalDpi xmlns:a14="http://schemas.microsoft.com/office/drawing/2010/main" val="0"/>
@@ -4911,6 +4915,36 @@
           <a:effectLst>
             <a:softEdge rad="112500"/>
           </a:effectLst>
+        </p:spPr>
+      </p:pic>
+      <p:pic>
+        <p:nvPicPr>
+          <p:cNvPr id="10" name="Picture 9">
+            <a:extLst>
+              <a:ext uri="{FF2B5EF4-FFF2-40B4-BE49-F238E27FC236}">
+                <a16:creationId xmlns:a16="http://schemas.microsoft.com/office/drawing/2014/main" id="{60C727CE-6255-82CB-CFCB-7738B389789F}"/>
+              </a:ext>
+            </a:extLst>
+          </p:cNvPr>
+          <p:cNvPicPr>
+            <a:picLocks noChangeAspect="1"/>
+          </p:cNvPicPr>
+          <p:nvPr userDrawn="1"/>
+        </p:nvPicPr>
+        <p:blipFill>
+          <a:blip r:embed="rId15"/>
+          <a:stretch>
+            <a:fillRect/>
+          </a:stretch>
+        </p:blipFill>
+        <p:spPr>
+          <a:xfrm>
+            <a:off x="0" y="165156"/>
+            <a:ext cx="2123320" cy="447651"/>
+          </a:xfrm>
+          <a:prstGeom prst="rect">
+            <a:avLst/>
+          </a:prstGeom>
         </p:spPr>
       </p:pic>
     </p:spTree>
@@ -20306,15 +20340,6 @@
 </file>
 
 <file path=customXml/item1.xml><?xml version="1.0" encoding="utf-8"?>
-<?mso-contentType ?>
-<FormTemplates xmlns="http://schemas.microsoft.com/sharepoint/v3/contenttype/forms">
-  <Display>DocumentLibraryForm</Display>
-  <Edit>DocumentLibraryForm</Edit>
-  <New>DocumentLibraryForm</New>
-</FormTemplates>
-</file>
-
-<file path=customXml/item2.xml><?xml version="1.0" encoding="utf-8"?>
 <ct:contentTypeSchema xmlns:ct="http://schemas.microsoft.com/office/2006/metadata/contentType" xmlns:ma="http://schemas.microsoft.com/office/2006/metadata/properties/metaAttributes" ct:_="" ma:_="" ma:contentTypeName="Document" ma:contentTypeID="0x010100D30DB0B4DCD4994BA0B53B90F48248FB" ma:contentTypeVersion="17" ma:contentTypeDescription="Create a new document." ma:contentTypeScope="" ma:versionID="89b596077de0219f935a6ab711f2d0ee">
   <xsd:schema xmlns:xsd="http://www.w3.org/2001/XMLSchema" xmlns:xs="http://www.w3.org/2001/XMLSchema" xmlns:p="http://schemas.microsoft.com/office/2006/metadata/properties" xmlns:ns3="5d9e8ea6-d7cf-4c00-b931-0c0027af1451" xmlns:ns4="24b8453d-154c-4c63-97d1-80f7846f6991" targetNamespace="http://schemas.microsoft.com/office/2006/metadata/properties" ma:root="true" ma:fieldsID="cd616adf96839ca32a36dfb6e4534def" ns3:_="" ns4:_="">
     <xsd:import namespace="5d9e8ea6-d7cf-4c00-b931-0c0027af1451"/>
@@ -20561,6 +20586,15 @@
 </ct:contentTypeSchema>
 </file>
 
+<file path=customXml/item2.xml><?xml version="1.0" encoding="utf-8"?>
+<?mso-contentType ?>
+<FormTemplates xmlns="http://schemas.microsoft.com/sharepoint/v3/contenttype/forms">
+  <Display>DocumentLibraryForm</Display>
+  <Edit>DocumentLibraryForm</Edit>
+  <New>DocumentLibraryForm</New>
+</FormTemplates>
+</file>
+
 <file path=customXml/item3.xml><?xml version="1.0" encoding="utf-8"?>
 <p:properties xmlns:p="http://schemas.microsoft.com/office/2006/metadata/properties" xmlns:xsi="http://www.w3.org/2001/XMLSchema-instance" xmlns:pc="http://schemas.microsoft.com/office/infopath/2007/PartnerControls">
   <documentManagement>
@@ -20570,14 +20604,6 @@
 </file>
 
 <file path=customXml/itemProps1.xml><?xml version="1.0" encoding="utf-8"?>
-<ds:datastoreItem xmlns:ds="http://schemas.openxmlformats.org/officeDocument/2006/customXml" ds:itemID="{45A00539-F935-4DAE-994B-29A86868AB4E}">
-  <ds:schemaRefs>
-    <ds:schemaRef ds:uri="http://schemas.microsoft.com/sharepoint/v3/contenttype/forms"/>
-  </ds:schemaRefs>
-</ds:datastoreItem>
-</file>
-
-<file path=customXml/itemProps2.xml><?xml version="1.0" encoding="utf-8"?>
 <ds:datastoreItem xmlns:ds="http://schemas.openxmlformats.org/officeDocument/2006/customXml" ds:itemID="{E49744A2-A4E7-4F10-8EA8-A7278CF8AA73}">
   <ds:schemaRefs>
     <ds:schemaRef ds:uri="http://schemas.microsoft.com/office/2006/metadata/contentType"/>
@@ -20592,6 +20618,14 @@
     <ds:schemaRef ds:uri="http://purl.org/dc/elements/1.1/"/>
     <ds:schemaRef ds:uri="http://purl.org/dc/terms/"/>
     <ds:schemaRef ds:uri="http://schemas.microsoft.com/internal/obd"/>
+  </ds:schemaRefs>
+</ds:datastoreItem>
+</file>
+
+<file path=customXml/itemProps2.xml><?xml version="1.0" encoding="utf-8"?>
+<ds:datastoreItem xmlns:ds="http://schemas.openxmlformats.org/officeDocument/2006/customXml" ds:itemID="{45A00539-F935-4DAE-994B-29A86868AB4E}">
+  <ds:schemaRefs>
+    <ds:schemaRef ds:uri="http://schemas.microsoft.com/sharepoint/v3/contenttype/forms"/>
   </ds:schemaRefs>
 </ds:datastoreItem>
 </file>

</xml_diff>